<commit_message>
docs: keep report visuals within slide bounds
Co-authored-by: 程序员鱼皮 <592789970@qq.com>
</commit_message>
<xml_diff>
--- a/docs/reports/project-status-2026-07-17.pptx
+++ b/docs/reports/project-status-2026-07-17.pptx
@@ -1888,8 +1888,8 @@
         </p:nvSpPr>
         <p:spPr>
           <a:xfrm rot="600000">
-            <a:off x="7772400" y="-1188720"/>
-            <a:ext cx="5669280" cy="5669280"/>
+            <a:off x="7772400" y="0"/>
+            <a:ext cx="4389120" cy="4389120"/>
           </a:xfrm>
           <a:prstGeom prst="arc">
             <a:avLst/>
@@ -1917,8 +1917,8 @@
         </p:nvSpPr>
         <p:spPr>
           <a:xfrm rot="12000000">
-            <a:off x="8321040" y="1920240"/>
-            <a:ext cx="5120640" cy="5120640"/>
+            <a:off x="8321040" y="2194560"/>
+            <a:ext cx="3749040" cy="3749040"/>
           </a:xfrm>
           <a:prstGeom prst="arc">
             <a:avLst/>

</xml_diff>